<commit_message>
build: patch deck PPTX to corrected stats/KPI/labels; e2e 19/19; submission-readiness report (P6)
</commit_message>
<xml_diff>
--- a/proposal/[LocalGuard] JB금융그룹 Fin AI Challenge MVP제안서.pptx
+++ b/proposal/[LocalGuard] JB금융그룹 Fin AI Challenge MVP제안서.pptx
@@ -313,41 +313,29 @@
           </c:dPt>
           <c:cat>
             <c:strRef>
-              <c:f>Sheet1!$A$2:$A$5</c:f>
+              <c:f>Sheet1!$A$2:$A$3</c:f>
               <c:strCache>
-                <c:ptCount val="4"/>
+                <c:ptCount val="2"/>
                 <c:pt idx="0">
-                  <c:v>2021</c:v>
+                  <c:v>2024년 1~11월</c:v>
                 </c:pt>
                 <c:pt idx="1">
-                  <c:v>2022</c:v>
-                </c:pt>
-                <c:pt idx="2">
-                  <c:v>2023</c:v>
-                </c:pt>
-                <c:pt idx="3">
-                  <c:v>2024</c:v>
+                  <c:v>2025년 1~11월</c:v>
                 </c:pt>
               </c:strCache>
             </c:strRef>
           </c:cat>
           <c:val>
             <c:numRef>
-              <c:f>Sheet1!$B$2:$B$5</c:f>
+              <c:f>Sheet1!$B$2:$B$3</c:f>
               <c:numCache>
                 <c:formatCode>General</c:formatCode>
-                <c:ptCount val="4"/>
+                <c:ptCount val="2"/>
                 <c:pt idx="0">
-                  <c:v>7744</c:v>
+                  <c:v>7263</c:v>
                 </c:pt>
                 <c:pt idx="1">
-                  <c:v>5438</c:v>
-                </c:pt>
-                <c:pt idx="2">
-                  <c:v>4472</c:v>
-                </c:pt>
-                <c:pt idx="3">
-                  <c:v>8545</c:v>
+                  <c:v>11330</c:v>
                 </c:pt>
               </c:numCache>
             </c:numRef>
@@ -15007,7 +14995,7 @@
                 <a:latin typeface="Pretendard"/>
                 <a:ea typeface="Pretendard"/>
               </a:rPr>
-              <a:t>8,545억 원</a:t>
+              <a:t>1.13조 원</a:t>
             </a:r>
           </a:p>
         </p:txBody>
@@ -15047,7 +15035,7 @@
                 <a:latin typeface="Pretendard"/>
                 <a:ea typeface="Pretendard"/>
               </a:rPr>
-              <a:t>2024년 보이스피싱 피해액 · 역대 최대</a:t>
+              <a:t>보이스피싱 피해액 (’25.1~11월)</a:t>
             </a:r>
           </a:p>
         </p:txBody>
@@ -15087,7 +15075,7 @@
                 <a:latin typeface="Pretendard"/>
                 <a:ea typeface="Pretendard"/>
               </a:rPr>
-              <a:t>전년 대비 약 2배 급증  |  경찰청 국가수사본부</a:t>
+              <a:t>전년 동기 대비 +56%  |  금융위·경찰청</a:t>
             </a:r>
           </a:p>
         </p:txBody>
@@ -15215,7 +15203,7 @@
                 <a:latin typeface="Pretendard"/>
                 <a:ea typeface="Pretendard"/>
               </a:rPr>
-              <a:t>전세사기 피해자 누적 결정 (’26.5 기준)</a:t>
+              <a:t>전세사기 피해자 누적 결정 (’26 기준)</a:t>
             </a:r>
           </a:p>
         </p:txBody>
@@ -15255,7 +15243,7 @@
                 <a:latin typeface="Pretendard"/>
                 <a:ea typeface="Pretendard"/>
               </a:rPr>
-              <a:t>’23.6 특별법 시행 후 계속 증가  |  국토교통부</a:t>
+              <a:t>HUG 사고액 ’24년 4.49조 원(역대 최대)  |  국토부·HUG</a:t>
             </a:r>
           </a:p>
         </p:txBody>
@@ -15343,7 +15331,7 @@
                 <a:latin typeface="Pretendard"/>
                 <a:ea typeface="Pretendard"/>
               </a:rPr>
-              <a:t>43.7만 명</a:t>
+              <a:t>42.7만 명</a:t>
             </a:r>
           </a:p>
         </p:txBody>
@@ -15383,7 +15371,7 @@
                 <a:latin typeface="Pretendard"/>
                 <a:ea typeface="Pretendard"/>
               </a:rPr>
-              <a:t>취약 자영업자 (’25.2분기) · 대출 약 130조 원</a:t>
+              <a:t>취약 자영업자 (’24말 · 13.7%)</a:t>
             </a:r>
           </a:p>
         </p:txBody>
@@ -15423,7 +15411,7 @@
                 <a:latin typeface="Pretendard"/>
                 <a:ea typeface="Pretendard"/>
               </a:rPr>
-              <a:t>취약차주 연체율 11%대  |  한국은행 금융안정 상황</a:t>
+              <a:t>취약차주 연체율 11.16%  |  한국은행 금융안정상황</a:t>
             </a:r>
           </a:p>
         </p:txBody>
@@ -23531,7 +23519,7 @@
                 <a:latin typeface="Pretendard"/>
                 <a:ea typeface="Pretendard"/>
               </a:rPr>
-              <a:t>대표 유스케이스 — 전세 보호  </a:t>
+              <a:t>유스케이스 상세 — 전세 보호 라인  (청년 고객이 전세계약 전에 은행을 통해 위험을 진단받는 흐름)</a:t>
             </a:r>
             <a:r>
               <a:rPr sz="900" b="0">
@@ -23541,7 +23529,7 @@
                 <a:latin typeface="Pretendard"/>
                 <a:ea typeface="Pretendard"/>
               </a:rPr>
-              <a:t>(청년 고객이 전세계약 전에 은행을 통해 위험을 진단받는 흐름)</a:t>
+              <a:t/>
             </a:r>
           </a:p>
         </p:txBody>
@@ -25270,7 +25258,7 @@
                 <a:latin typeface="Pretendard"/>
                 <a:ea typeface="Pretendard"/>
               </a:rPr>
-              <a:t>보조 유스케이스 — 소상공인 자금압박 케어</a:t>
+              <a:t>대표 케이스 — 전주 카페 자금압박 케어 (JBG-104)</a:t>
             </a:r>
           </a:p>
         </p:txBody>
@@ -26832,7 +26820,7 @@
                 <a:latin typeface="Pretendard"/>
                 <a:ea typeface="Pretendard"/>
               </a:rPr>
-              <a:t>고위험 사기 케이스 외부 발송</a:t>
+              <a:t>사후관리 누락 (후속 태스크 자동 등록)</a:t>
             </a:r>
           </a:p>
         </p:txBody>
@@ -26872,7 +26860,7 @@
                 <a:latin typeface="Pretendard"/>
                 <a:ea typeface="Pretendard"/>
               </a:rPr>
-              <a:t>사기 차단 에이전트가 자동 차단 · 보안 보고만</a:t>
+              <a:t>고위험 사기 케이스 외부 발송도 이상거래 탐지·차단 에이전트가 자동 차단</a:t>
             </a:r>
           </a:p>
         </p:txBody>

</xml_diff>